<commit_message>
ForestMRV v2.11.37 -> v2.11.39: 採收回報及結案分頁 + G1/G2/G3 收穫回報閘門 + 併 PWA iOS 死鎖修復
新增「採收回報及結案」分頁 renderHarvestReport：林農核准後在獨立分頁填報實際採收量、回報完畢並結案，補資訊架構缺口（申請→審核→回報及結案→彙整）；申請卡改指路。
G1 結案閘門 client + firestore.rules 雙擋零回報結案（rules clause C 並堵 approved 直跳 completed）。
G2 未回報紅幅明示強制回報。G3 合作社彙整改並列 申請量／已回報／達成率。
併入先前未部署的 PWA iOS 卡死死鎖修復（SW skipWaiting + 導航 network-first + index.html ESM graph 外 inline 逃生引導）。
版本 v2.11.39 全檔 lockstep（50 處 ?v=21137 至 21139 + SW CACHE/JS_VERSION）。
5/20 簡報 slide 9 連動重生（G3 並列欄位）。
prod 未部署（worktree 缺 firebase-config.js）；deploy 須從主 checkout 並含 firestore:rules。

Co-Authored-By: Claude Opus 4.7 (1M context) <noreply@anthropic.com>
</commit_message>
<xml_diff>
--- a/reports/2026-05-mid-demo/05-土肉桂採收許可-520說明會簡報.pptx
+++ b/reports/2026-05-mid-demo/05-土肉桂採收許可-520說明會簡報.pptx
@@ -1570,7 +1570,7 @@
           <a:p>
             <a:r>
               <a:rPr lang="en-US" dirty="0"/>
-              <a:t>這是合作社最在意的一頁。上方三個數字一眼看懂規模；下方表格依林農拆解：已實現就是可以投入共同銷售的量，Pipeline 是還在流程中的預估量。合作社用這頁規劃共同銷售。數字都是現在系統裡的真實 demo 資料。</a:t>
+              <a:t>這是合作社最在意的一頁，與系統「採收彙整」分頁 1:1。三個數字：申請案 9 件、申請當時總量 625 kg、事後實際回報 168 kg（整體達成率 27%）。下表依林農拆解、依「已回報」由多到少排序：申請量＝申請當時預計、已回報＝事後實際採收回報（即可投入共同銷售之量）、達成率＝已回報÷申請量。所有數字都是系統裡真實 demo 資料，現場切合作社帳號可逐列對照。註：用途欄帶 kg，尚未回報者 0.0 屬正常；王美桂含一件補件中案（兩者皆有 0.0）。零已回報各列先後由系統即時排序，與判讀無關。</a:t>
             </a:r>
             <a:endParaRPr lang="en-US" dirty="0"/>
           </a:p>
@@ -9881,7 +9881,7 @@
               <a:buNone/>
             </a:pPr>
             <a:r>
-              <a:rPr lang="en-US" sz="2400" b="1" dirty="0">
+              <a:rPr lang="en-US" sz="2200" b="1" dirty="0">
                 <a:solidFill>
                   <a:srgbClr val="2C5F2D"/>
                 </a:solidFill>
@@ -9891,7 +9891,7 @@
               </a:rPr>
               <a:t>9 件</a:t>
             </a:r>
-            <a:endParaRPr lang="en-US" sz="2400" dirty="0"/>
+            <a:endParaRPr lang="en-US" sz="2200" dirty="0"/>
           </a:p>
         </p:txBody>
       </p:sp>
@@ -9920,7 +9920,7 @@
               <a:buNone/>
             </a:pPr>
             <a:r>
-              <a:rPr lang="en-US" sz="1250" dirty="0">
+              <a:rPr lang="en-US" sz="1200" dirty="0">
                 <a:solidFill>
                   <a:srgbClr val="5F6B5A"/>
                 </a:solidFill>
@@ -9930,7 +9930,7 @@
               </a:rPr>
               <a:t>申請案（已送出起）</a:t>
             </a:r>
-            <a:endParaRPr lang="en-US" sz="1250" dirty="0"/>
+            <a:endParaRPr lang="en-US" sz="1200" dirty="0"/>
           </a:p>
         </p:txBody>
       </p:sp>
@@ -9986,7 +9986,7 @@
               <a:buNone/>
             </a:pPr>
             <a:r>
-              <a:rPr lang="en-US" sz="2400" b="1" dirty="0">
+              <a:rPr lang="en-US" sz="2200" b="1" dirty="0">
                 <a:solidFill>
                   <a:srgbClr val="2C5F2D"/>
                 </a:solidFill>
@@ -9994,9 +9994,9 @@
                 <a:ea typeface="Microsoft JhengHei" pitchFamily="34" charset="-122"/>
                 <a:cs typeface="Microsoft JhengHei" pitchFamily="34" charset="-120"/>
               </a:rPr>
-              <a:t>5 件</a:t>
-            </a:r>
-            <a:endParaRPr lang="en-US" sz="2400" dirty="0"/>
+              <a:t>625.0 kg</a:t>
+            </a:r>
+            <a:endParaRPr lang="en-US" sz="2200" dirty="0"/>
           </a:p>
         </p:txBody>
       </p:sp>
@@ -10025,7 +10025,7 @@
               <a:buNone/>
             </a:pPr>
             <a:r>
-              <a:rPr lang="en-US" sz="1250" dirty="0">
+              <a:rPr lang="en-US" sz="1200" dirty="0">
                 <a:solidFill>
                   <a:srgbClr val="5F6B5A"/>
                 </a:solidFill>
@@ -10033,9 +10033,9 @@
                 <a:ea typeface="Microsoft JhengHei" pitchFamily="34" charset="-122"/>
                 <a:cs typeface="Microsoft JhengHei" pitchFamily="34" charset="-120"/>
               </a:rPr>
-              <a:t>已核准 / 採收 / 結案</a:t>
-            </a:r>
-            <a:endParaRPr lang="en-US" sz="1250" dirty="0"/>
+              <a:t>申請總量（申請當時）</a:t>
+            </a:r>
+            <a:endParaRPr lang="en-US" sz="1200" dirty="0"/>
           </a:p>
         </p:txBody>
       </p:sp>
@@ -10091,7 +10091,7 @@
               <a:buNone/>
             </a:pPr>
             <a:r>
-              <a:rPr lang="en-US" sz="2400" b="1" dirty="0">
+              <a:rPr lang="en-US" sz="2200" b="1" dirty="0">
                 <a:solidFill>
                   <a:srgbClr val="FFFFFF"/>
                 </a:solidFill>
@@ -10099,9 +10099,9 @@
                 <a:ea typeface="Microsoft JhengHei" pitchFamily="34" charset="-122"/>
                 <a:cs typeface="Microsoft JhengHei" pitchFamily="34" charset="-120"/>
               </a:rPr>
-              <a:t>168 kg</a:t>
-            </a:r>
-            <a:endParaRPr lang="en-US" sz="2400" dirty="0"/>
+              <a:t>168.0 kg</a:t>
+            </a:r>
+            <a:endParaRPr lang="en-US" sz="2200" dirty="0"/>
           </a:p>
         </p:txBody>
       </p:sp>
@@ -10130,7 +10130,7 @@
               <a:buNone/>
             </a:pPr>
             <a:r>
-              <a:rPr lang="en-US" sz="1250" dirty="0">
+              <a:rPr lang="en-US" sz="1200" dirty="0">
                 <a:solidFill>
                   <a:srgbClr val="E6EEDD"/>
                 </a:solidFill>
@@ -10138,9 +10138,9 @@
                 <a:ea typeface="Microsoft JhengHei" pitchFamily="34" charset="-122"/>
                 <a:cs typeface="Microsoft JhengHei" pitchFamily="34" charset="-120"/>
               </a:rPr>
-              <a:t>已實現可售鮮葉</a:t>
-            </a:r>
-            <a:endParaRPr lang="en-US" sz="1250" dirty="0"/>
+              <a:t>已回報・達成率 27%</a:t>
+            </a:r>
+            <a:endParaRPr lang="en-US" sz="1200" dirty="0"/>
           </a:p>
         </p:txBody>
       </p:sp>
@@ -10167,11 +10167,12 @@
             <a:tbl>
               <a:tblPr/>
               <a:tblGrid>
-                <a:gridCol w="2194560"/>
                 <a:gridCol w="1554480"/>
-                <a:gridCol w="2743200"/>
-                <a:gridCol w="2651760"/>
-                <a:gridCol w="1764792"/>
+                <a:gridCol w="914400"/>
+                <a:gridCol w="1737360"/>
+                <a:gridCol w="1737360"/>
+                <a:gridCol w="1005840"/>
+                <a:gridCol w="3962095"/>
               </a:tblGrid>
               <a:tr h="384048">
                 <a:tc>
@@ -10183,7 +10184,7 @@
                         <a:buNone/>
                       </a:pPr>
                       <a:r>
-                        <a:rPr lang="en-US" sz="1350" b="1" dirty="0">
+                        <a:rPr lang="en-US" sz="1250" b="1" dirty="0">
                           <a:solidFill>
                             <a:srgbClr val="FFFFFF"/>
                           </a:solidFill>
@@ -10193,7 +10194,7 @@
                         </a:rPr>
                         <a:t>林農</a:t>
                       </a:r>
-                      <a:endParaRPr lang="en-US" sz="1350" dirty="0">
+                      <a:endParaRPr lang="en-US" sz="1250" dirty="0">
                         <a:latin typeface="Microsoft JhengHei" charset="0"/>
                         <a:ea typeface="Microsoft JhengHei" charset="0"/>
                         <a:cs typeface="Microsoft JhengHei" charset="0"/>
@@ -10251,7 +10252,7 @@
                         <a:buNone/>
                       </a:pPr>
                       <a:r>
-                        <a:rPr lang="en-US" sz="1350" b="1" dirty="0">
+                        <a:rPr lang="en-US" sz="1250" b="1" dirty="0">
                           <a:solidFill>
                             <a:srgbClr val="FFFFFF"/>
                           </a:solidFill>
@@ -10261,7 +10262,7 @@
                         </a:rPr>
                         <a:t>案件數</a:t>
                       </a:r>
-                      <a:endParaRPr lang="en-US" sz="1350" dirty="0">
+                      <a:endParaRPr lang="en-US" sz="1250" dirty="0">
                         <a:latin typeface="Microsoft JhengHei" charset="0"/>
                         <a:ea typeface="Microsoft JhengHei" charset="0"/>
                         <a:cs typeface="Microsoft JhengHei" charset="0"/>
@@ -10319,7 +10320,7 @@
                         <a:buNone/>
                       </a:pPr>
                       <a:r>
-                        <a:rPr lang="en-US" sz="1350" b="1" dirty="0">
+                        <a:rPr lang="en-US" sz="1250" b="1" dirty="0">
                           <a:solidFill>
                             <a:srgbClr val="FFFFFF"/>
                           </a:solidFill>
@@ -10327,9 +10328,9 @@
                           <a:ea typeface="Microsoft JhengHei" pitchFamily="34" charset="-122"/>
                           <a:cs typeface="Microsoft JhengHei" pitchFamily="34" charset="-120"/>
                         </a:rPr>
-                        <a:t>已實現鮮葉(kg)</a:t>
+                        <a:t>申請量(kg)</a:t>
                       </a:r>
-                      <a:endParaRPr lang="en-US" sz="1350" dirty="0">
+                      <a:endParaRPr lang="en-US" sz="1250" dirty="0">
                         <a:latin typeface="Microsoft JhengHei" charset="0"/>
                         <a:ea typeface="Microsoft JhengHei" charset="0"/>
                         <a:cs typeface="Microsoft JhengHei" charset="0"/>
@@ -10387,7 +10388,7 @@
                         <a:buNone/>
                       </a:pPr>
                       <a:r>
-                        <a:rPr lang="en-US" sz="1350" b="1" dirty="0">
+                        <a:rPr lang="en-US" sz="1250" b="1" dirty="0">
                           <a:solidFill>
                             <a:srgbClr val="FFFFFF"/>
                           </a:solidFill>
@@ -10395,9 +10396,9 @@
                           <a:ea typeface="Microsoft JhengHei" pitchFamily="34" charset="-122"/>
                           <a:cs typeface="Microsoft JhengHei" pitchFamily="34" charset="-120"/>
                         </a:rPr>
-                        <a:t>Pipeline估(kg)</a:t>
+                        <a:t>已回報(kg)</a:t>
                       </a:r>
-                      <a:endParaRPr lang="en-US" sz="1350" dirty="0">
+                      <a:endParaRPr lang="en-US" sz="1250" dirty="0">
                         <a:latin typeface="Microsoft JhengHei" charset="0"/>
                         <a:ea typeface="Microsoft JhengHei" charset="0"/>
                         <a:cs typeface="Microsoft JhengHei" charset="0"/>
@@ -10455,7 +10456,7 @@
                         <a:buNone/>
                       </a:pPr>
                       <a:r>
-                        <a:rPr lang="en-US" sz="1350" b="1" dirty="0">
+                        <a:rPr lang="en-US" sz="1250" b="1" dirty="0">
                           <a:solidFill>
                             <a:srgbClr val="FFFFFF"/>
                           </a:solidFill>
@@ -10463,9 +10464,77 @@
                           <a:ea typeface="Microsoft JhengHei" pitchFamily="34" charset="-122"/>
                           <a:cs typeface="Microsoft JhengHei" pitchFamily="34" charset="-120"/>
                         </a:rPr>
-                        <a:t>用途</a:t>
+                        <a:t>達成率</a:t>
                       </a:r>
-                      <a:endParaRPr lang="en-US" sz="1350" dirty="0">
+                      <a:endParaRPr lang="en-US" sz="1250" dirty="0">
+                        <a:latin typeface="Microsoft JhengHei" charset="0"/>
+                        <a:ea typeface="Microsoft JhengHei" charset="0"/>
+                        <a:cs typeface="Microsoft JhengHei" charset="0"/>
+                      </a:endParaRPr>
+                    </a:p>
+                  </a:txBody>
+                  <a:tcPr marL="91440" marR="91440" marT="45720" marB="45720" anchor="ctr">
+                    <a:lnL w="12700" cap="flat" cmpd="sng" algn="ctr">
+                      <a:solidFill>
+                        <a:srgbClr val="CBD5C0"/>
+                      </a:solidFill>
+                      <a:prstDash val="solid"/>
+                      <a:round/>
+                      <a:headEnd type="none" w="med" len="med"/>
+                      <a:tailEnd type="none" w="med" len="med"/>
+                    </a:lnL>
+                    <a:lnR w="12700" cap="flat" cmpd="sng" algn="ctr">
+                      <a:solidFill>
+                        <a:srgbClr val="CBD5C0"/>
+                      </a:solidFill>
+                      <a:prstDash val="solid"/>
+                      <a:round/>
+                      <a:headEnd type="none" w="med" len="med"/>
+                      <a:tailEnd type="none" w="med" len="med"/>
+                    </a:lnR>
+                    <a:lnT w="12700" cap="flat" cmpd="sng" algn="ctr">
+                      <a:solidFill>
+                        <a:srgbClr val="CBD5C0"/>
+                      </a:solidFill>
+                      <a:prstDash val="solid"/>
+                      <a:round/>
+                      <a:headEnd type="none" w="med" len="med"/>
+                      <a:tailEnd type="none" w="med" len="med"/>
+                    </a:lnT>
+                    <a:lnB w="12700" cap="flat" cmpd="sng" algn="ctr">
+                      <a:solidFill>
+                        <a:srgbClr val="CBD5C0"/>
+                      </a:solidFill>
+                      <a:prstDash val="solid"/>
+                      <a:round/>
+                      <a:headEnd type="none" w="med" len="med"/>
+                      <a:tailEnd type="none" w="med" len="med"/>
+                    </a:lnB>
+                    <a:solidFill>
+                      <a:srgbClr val="2C5F2D"/>
+                    </a:solidFill>
+                  </a:tcPr>
+                </a:tc>
+                <a:tc>
+                  <a:txBody>
+                    <a:bodyPr/>
+                    <a:lstStyle/>
+                    <a:p>
+                      <a:pPr indent="0" marL="0">
+                        <a:buNone/>
+                      </a:pPr>
+                      <a:r>
+                        <a:rPr lang="en-US" sz="1250" b="1" dirty="0">
+                          <a:solidFill>
+                            <a:srgbClr val="FFFFFF"/>
+                          </a:solidFill>
+                          <a:latin typeface="Microsoft JhengHei" pitchFamily="34" charset="0"/>
+                          <a:ea typeface="Microsoft JhengHei" pitchFamily="34" charset="-122"/>
+                          <a:cs typeface="Microsoft JhengHei" pitchFamily="34" charset="-120"/>
+                        </a:rPr>
+                        <a:t>用途分布(kg)</a:t>
+                      </a:r>
+                      <a:endParaRPr lang="en-US" sz="1250" dirty="0">
                         <a:latin typeface="Microsoft JhengHei" charset="0"/>
                         <a:ea typeface="Microsoft JhengHei" charset="0"/>
                         <a:cs typeface="Microsoft JhengHei" charset="0"/>
@@ -10525,7 +10594,7 @@
                         <a:buNone/>
                       </a:pPr>
                       <a:r>
-                        <a:rPr lang="en-US" sz="1250" b="1" dirty="0">
+                        <a:rPr lang="en-US" sz="1200" b="1" dirty="0">
                           <a:solidFill>
                             <a:srgbClr val="23311F"/>
                           </a:solidFill>
@@ -10533,9 +10602,9 @@
                           <a:ea typeface="Microsoft JhengHei" pitchFamily="34" charset="-122"/>
                           <a:cs typeface="Microsoft JhengHei" pitchFamily="34" charset="-120"/>
                         </a:rPr>
-                        <a:t>林大山</a:t>
+                        <a:t>吳國雄</a:t>
                       </a:r>
-                      <a:endParaRPr lang="en-US" sz="1250" dirty="0">
+                      <a:endParaRPr lang="en-US" sz="1200" dirty="0">
                         <a:latin typeface="Microsoft JhengHei" charset="0"/>
                         <a:ea typeface="Microsoft JhengHei" charset="0"/>
                         <a:cs typeface="Microsoft JhengHei" charset="0"/>
@@ -10593,7 +10662,7 @@
                         <a:buNone/>
                       </a:pPr>
                       <a:r>
-                        <a:rPr lang="en-US" sz="1250" dirty="0">
+                        <a:rPr lang="en-US" sz="1200" dirty="0">
                           <a:solidFill>
                             <a:srgbClr val="23311F"/>
                           </a:solidFill>
@@ -10601,9 +10670,9 @@
                           <a:ea typeface="Microsoft JhengHei" pitchFamily="34" charset="-122"/>
                           <a:cs typeface="Microsoft JhengHei" pitchFamily="34" charset="-120"/>
                         </a:rPr>
-                        <a:t>2</a:t>
+                        <a:t>1</a:t>
                       </a:r>
-                      <a:endParaRPr lang="en-US" sz="1250" dirty="0">
+                      <a:endParaRPr lang="en-US" sz="1200" dirty="0">
                         <a:latin typeface="Microsoft JhengHei" charset="0"/>
                         <a:ea typeface="Microsoft JhengHei" charset="0"/>
                         <a:cs typeface="Microsoft JhengHei" charset="0"/>
@@ -10661,7 +10730,7 @@
                         <a:buNone/>
                       </a:pPr>
                       <a:r>
-                        <a:rPr lang="en-US" sz="1250" dirty="0">
+                        <a:rPr lang="en-US" sz="1200" dirty="0">
                           <a:solidFill>
                             <a:srgbClr val="23311F"/>
                           </a:solidFill>
@@ -10669,9 +10738,9 @@
                           <a:ea typeface="Microsoft JhengHei" pitchFamily="34" charset="-122"/>
                           <a:cs typeface="Microsoft JhengHei" pitchFamily="34" charset="-120"/>
                         </a:rPr>
-                        <a:t>45</a:t>
+                        <a:t>100.0</a:t>
                       </a:r>
-                      <a:endParaRPr lang="en-US" sz="1250" dirty="0">
+                      <a:endParaRPr lang="en-US" sz="1200" dirty="0">
                         <a:latin typeface="Microsoft JhengHei" charset="0"/>
                         <a:ea typeface="Microsoft JhengHei" charset="0"/>
                         <a:cs typeface="Microsoft JhengHei" charset="0"/>
@@ -10729,7 +10798,7 @@
                         <a:buNone/>
                       </a:pPr>
                       <a:r>
-                        <a:rPr lang="en-US" sz="1250" dirty="0">
+                        <a:rPr lang="en-US" sz="1200" dirty="0">
                           <a:solidFill>
                             <a:srgbClr val="23311F"/>
                           </a:solidFill>
@@ -10737,9 +10806,77 @@
                           <a:ea typeface="Microsoft JhengHei" pitchFamily="34" charset="-122"/>
                           <a:cs typeface="Microsoft JhengHei" pitchFamily="34" charset="-120"/>
                         </a:rPr>
-                        <a:t>60</a:t>
+                        <a:t>85.0</a:t>
                       </a:r>
-                      <a:endParaRPr lang="en-US" sz="1250" dirty="0">
+                      <a:endParaRPr lang="en-US" sz="1200" dirty="0">
+                        <a:latin typeface="Microsoft JhengHei" charset="0"/>
+                        <a:ea typeface="Microsoft JhengHei" charset="0"/>
+                        <a:cs typeface="Microsoft JhengHei" charset="0"/>
+                      </a:endParaRPr>
+                    </a:p>
+                  </a:txBody>
+                  <a:tcPr marL="91440" marR="91440" marT="45720" marB="45720" anchor="ctr">
+                    <a:lnL w="12700" cap="flat" cmpd="sng" algn="ctr">
+                      <a:solidFill>
+                        <a:srgbClr val="CBD5C0"/>
+                      </a:solidFill>
+                      <a:prstDash val="solid"/>
+                      <a:round/>
+                      <a:headEnd type="none" w="med" len="med"/>
+                      <a:tailEnd type="none" w="med" len="med"/>
+                    </a:lnL>
+                    <a:lnR w="12700" cap="flat" cmpd="sng" algn="ctr">
+                      <a:solidFill>
+                        <a:srgbClr val="CBD5C0"/>
+                      </a:solidFill>
+                      <a:prstDash val="solid"/>
+                      <a:round/>
+                      <a:headEnd type="none" w="med" len="med"/>
+                      <a:tailEnd type="none" w="med" len="med"/>
+                    </a:lnR>
+                    <a:lnT w="12700" cap="flat" cmpd="sng" algn="ctr">
+                      <a:solidFill>
+                        <a:srgbClr val="CBD5C0"/>
+                      </a:solidFill>
+                      <a:prstDash val="solid"/>
+                      <a:round/>
+                      <a:headEnd type="none" w="med" len="med"/>
+                      <a:tailEnd type="none" w="med" len="med"/>
+                    </a:lnT>
+                    <a:lnB w="12700" cap="flat" cmpd="sng" algn="ctr">
+                      <a:solidFill>
+                        <a:srgbClr val="CBD5C0"/>
+                      </a:solidFill>
+                      <a:prstDash val="solid"/>
+                      <a:round/>
+                      <a:headEnd type="none" w="med" len="med"/>
+                      <a:tailEnd type="none" w="med" len="med"/>
+                    </a:lnB>
+                    <a:solidFill>
+                      <a:srgbClr val="FFFFFF"/>
+                    </a:solidFill>
+                  </a:tcPr>
+                </a:tc>
+                <a:tc>
+                  <a:txBody>
+                    <a:bodyPr/>
+                    <a:lstStyle/>
+                    <a:p>
+                      <a:pPr algn="ctr" indent="0" marL="0">
+                        <a:buNone/>
+                      </a:pPr>
+                      <a:r>
+                        <a:rPr lang="en-US" sz="1200" dirty="0">
+                          <a:solidFill>
+                            <a:srgbClr val="23311F"/>
+                          </a:solidFill>
+                          <a:latin typeface="Microsoft JhengHei" pitchFamily="34" charset="0"/>
+                          <a:ea typeface="Microsoft JhengHei" pitchFamily="34" charset="-122"/>
+                          <a:cs typeface="Microsoft JhengHei" pitchFamily="34" charset="-120"/>
+                        </a:rPr>
+                        <a:t>85%</a:t>
+                      </a:r>
+                      <a:endParaRPr lang="en-US" sz="1200" dirty="0">
                         <a:latin typeface="Microsoft JhengHei" charset="0"/>
                         <a:ea typeface="Microsoft JhengHei" charset="0"/>
                         <a:cs typeface="Microsoft JhengHei" charset="0"/>
@@ -10797,7 +10934,7 @@
                         <a:buNone/>
                       </a:pPr>
                       <a:r>
-                        <a:rPr lang="en-US" sz="1250" dirty="0">
+                        <a:rPr lang="en-US" sz="1200" dirty="0">
                           <a:solidFill>
                             <a:srgbClr val="23311F"/>
                           </a:solidFill>
@@ -10805,9 +10942,9 @@
                           <a:ea typeface="Microsoft JhengHei" pitchFamily="34" charset="-122"/>
                           <a:cs typeface="Microsoft JhengHei" pitchFamily="34" charset="-120"/>
                         </a:rPr>
-                        <a:t>精油萃取</a:t>
+                        <a:t>兩者皆有 85.0</a:t>
                       </a:r>
-                      <a:endParaRPr lang="en-US" sz="1250" dirty="0">
+                      <a:endParaRPr lang="en-US" sz="1200" dirty="0">
                         <a:latin typeface="Microsoft JhengHei" charset="0"/>
                         <a:ea typeface="Microsoft JhengHei" charset="0"/>
                         <a:cs typeface="Microsoft JhengHei" charset="0"/>
@@ -10867,7 +11004,7 @@
                         <a:buNone/>
                       </a:pPr>
                       <a:r>
-                        <a:rPr lang="en-US" sz="1250" b="1" dirty="0">
+                        <a:rPr lang="en-US" sz="1200" b="1" dirty="0">
                           <a:solidFill>
                             <a:srgbClr val="23311F"/>
                           </a:solidFill>
@@ -10875,9 +11012,9 @@
                           <a:ea typeface="Microsoft JhengHei" pitchFamily="34" charset="-122"/>
                           <a:cs typeface="Microsoft JhengHei" pitchFamily="34" charset="-120"/>
                         </a:rPr>
-                        <a:t>吳國雄</a:t>
+                        <a:t>林大山</a:t>
                       </a:r>
-                      <a:endParaRPr lang="en-US" sz="1250" dirty="0">
+                      <a:endParaRPr lang="en-US" sz="1200" dirty="0">
                         <a:latin typeface="Microsoft JhengHei" charset="0"/>
                         <a:ea typeface="Microsoft JhengHei" charset="0"/>
                         <a:cs typeface="Microsoft JhengHei" charset="0"/>
@@ -10935,7 +11072,7 @@
                         <a:buNone/>
                       </a:pPr>
                       <a:r>
-                        <a:rPr lang="en-US" sz="1250" dirty="0">
+                        <a:rPr lang="en-US" sz="1200" dirty="0">
                           <a:solidFill>
                             <a:srgbClr val="23311F"/>
                           </a:solidFill>
@@ -10943,9 +11080,9 @@
                           <a:ea typeface="Microsoft JhengHei" pitchFamily="34" charset="-122"/>
                           <a:cs typeface="Microsoft JhengHei" pitchFamily="34" charset="-120"/>
                         </a:rPr>
-                        <a:t>1</a:t>
+                        <a:t>2</a:t>
                       </a:r>
-                      <a:endParaRPr lang="en-US" sz="1250" dirty="0">
+                      <a:endParaRPr lang="en-US" sz="1200" dirty="0">
                         <a:latin typeface="Microsoft JhengHei" charset="0"/>
                         <a:ea typeface="Microsoft JhengHei" charset="0"/>
                         <a:cs typeface="Microsoft JhengHei" charset="0"/>
@@ -11003,7 +11140,7 @@
                         <a:buNone/>
                       </a:pPr>
                       <a:r>
-                        <a:rPr lang="en-US" sz="1250" dirty="0">
+                        <a:rPr lang="en-US" sz="1200" dirty="0">
                           <a:solidFill>
                             <a:srgbClr val="23311F"/>
                           </a:solidFill>
@@ -11011,9 +11148,9 @@
                           <a:ea typeface="Microsoft JhengHei" pitchFamily="34" charset="-122"/>
                           <a:cs typeface="Microsoft JhengHei" pitchFamily="34" charset="-120"/>
                         </a:rPr>
-                        <a:t>85</a:t>
+                        <a:t>120.0</a:t>
                       </a:r>
-                      <a:endParaRPr lang="en-US" sz="1250" dirty="0">
+                      <a:endParaRPr lang="en-US" sz="1200" dirty="0">
                         <a:latin typeface="Microsoft JhengHei" charset="0"/>
                         <a:ea typeface="Microsoft JhengHei" charset="0"/>
                         <a:cs typeface="Microsoft JhengHei" charset="0"/>
@@ -11071,7 +11208,7 @@
                         <a:buNone/>
                       </a:pPr>
                       <a:r>
-                        <a:rPr lang="en-US" sz="1250" dirty="0">
+                        <a:rPr lang="en-US" sz="1200" dirty="0">
                           <a:solidFill>
                             <a:srgbClr val="23311F"/>
                           </a:solidFill>
@@ -11079,9 +11216,77 @@
                           <a:ea typeface="Microsoft JhengHei" pitchFamily="34" charset="-122"/>
                           <a:cs typeface="Microsoft JhengHei" pitchFamily="34" charset="-120"/>
                         </a:rPr>
-                        <a:t>0</a:t>
+                        <a:t>45.0</a:t>
                       </a:r>
-                      <a:endParaRPr lang="en-US" sz="1250" dirty="0">
+                      <a:endParaRPr lang="en-US" sz="1200" dirty="0">
+                        <a:latin typeface="Microsoft JhengHei" charset="0"/>
+                        <a:ea typeface="Microsoft JhengHei" charset="0"/>
+                        <a:cs typeface="Microsoft JhengHei" charset="0"/>
+                      </a:endParaRPr>
+                    </a:p>
+                  </a:txBody>
+                  <a:tcPr marL="91440" marR="91440" marT="45720" marB="45720" anchor="ctr">
+                    <a:lnL w="12700" cap="flat" cmpd="sng" algn="ctr">
+                      <a:solidFill>
+                        <a:srgbClr val="CBD5C0"/>
+                      </a:solidFill>
+                      <a:prstDash val="solid"/>
+                      <a:round/>
+                      <a:headEnd type="none" w="med" len="med"/>
+                      <a:tailEnd type="none" w="med" len="med"/>
+                    </a:lnL>
+                    <a:lnR w="12700" cap="flat" cmpd="sng" algn="ctr">
+                      <a:solidFill>
+                        <a:srgbClr val="CBD5C0"/>
+                      </a:solidFill>
+                      <a:prstDash val="solid"/>
+                      <a:round/>
+                      <a:headEnd type="none" w="med" len="med"/>
+                      <a:tailEnd type="none" w="med" len="med"/>
+                    </a:lnR>
+                    <a:lnT w="12700" cap="flat" cmpd="sng" algn="ctr">
+                      <a:solidFill>
+                        <a:srgbClr val="CBD5C0"/>
+                      </a:solidFill>
+                      <a:prstDash val="solid"/>
+                      <a:round/>
+                      <a:headEnd type="none" w="med" len="med"/>
+                      <a:tailEnd type="none" w="med" len="med"/>
+                    </a:lnT>
+                    <a:lnB w="12700" cap="flat" cmpd="sng" algn="ctr">
+                      <a:solidFill>
+                        <a:srgbClr val="CBD5C0"/>
+                      </a:solidFill>
+                      <a:prstDash val="solid"/>
+                      <a:round/>
+                      <a:headEnd type="none" w="med" len="med"/>
+                      <a:tailEnd type="none" w="med" len="med"/>
+                    </a:lnB>
+                    <a:solidFill>
+                      <a:srgbClr val="F4F6F1"/>
+                    </a:solidFill>
+                  </a:tcPr>
+                </a:tc>
+                <a:tc>
+                  <a:txBody>
+                    <a:bodyPr/>
+                    <a:lstStyle/>
+                    <a:p>
+                      <a:pPr algn="ctr" indent="0" marL="0">
+                        <a:buNone/>
+                      </a:pPr>
+                      <a:r>
+                        <a:rPr lang="en-US" sz="1200" dirty="0">
+                          <a:solidFill>
+                            <a:srgbClr val="23311F"/>
+                          </a:solidFill>
+                          <a:latin typeface="Microsoft JhengHei" pitchFamily="34" charset="0"/>
+                          <a:ea typeface="Microsoft JhengHei" pitchFamily="34" charset="-122"/>
+                          <a:cs typeface="Microsoft JhengHei" pitchFamily="34" charset="-120"/>
+                        </a:rPr>
+                        <a:t>38%</a:t>
+                      </a:r>
+                      <a:endParaRPr lang="en-US" sz="1200" dirty="0">
                         <a:latin typeface="Microsoft JhengHei" charset="0"/>
                         <a:ea typeface="Microsoft JhengHei" charset="0"/>
                         <a:cs typeface="Microsoft JhengHei" charset="0"/>
@@ -11139,7 +11344,7 @@
                         <a:buNone/>
                       </a:pPr>
                       <a:r>
-                        <a:rPr lang="en-US" sz="1250" dirty="0">
+                        <a:rPr lang="en-US" sz="1200" dirty="0">
                           <a:solidFill>
                             <a:srgbClr val="23311F"/>
                           </a:solidFill>
@@ -11147,9 +11352,9 @@
                           <a:ea typeface="Microsoft JhengHei" pitchFamily="34" charset="-122"/>
                           <a:cs typeface="Microsoft JhengHei" pitchFamily="34" charset="-120"/>
                         </a:rPr>
-                        <a:t>兩者皆有</a:t>
+                        <a:t>精油萃取 45.0</a:t>
                       </a:r>
-                      <a:endParaRPr lang="en-US" sz="1250" dirty="0">
+                      <a:endParaRPr lang="en-US" sz="1200" dirty="0">
                         <a:latin typeface="Microsoft JhengHei" charset="0"/>
                         <a:ea typeface="Microsoft JhengHei" charset="0"/>
                         <a:cs typeface="Microsoft JhengHei" charset="0"/>
@@ -11209,7 +11414,7 @@
                         <a:buNone/>
                       </a:pPr>
                       <a:r>
-                        <a:rPr lang="en-US" sz="1250" b="1" dirty="0">
+                        <a:rPr lang="en-US" sz="1200" b="1" dirty="0">
                           <a:solidFill>
                             <a:srgbClr val="23311F"/>
                           </a:solidFill>
@@ -11219,7 +11424,7 @@
                         </a:rPr>
                         <a:t>王美桂</a:t>
                       </a:r>
-                      <a:endParaRPr lang="en-US" sz="1250" dirty="0">
+                      <a:endParaRPr lang="en-US" sz="1200" dirty="0">
                         <a:latin typeface="Microsoft JhengHei" charset="0"/>
                         <a:ea typeface="Microsoft JhengHei" charset="0"/>
                         <a:cs typeface="Microsoft JhengHei" charset="0"/>
@@ -11277,7 +11482,7 @@
                         <a:buNone/>
                       </a:pPr>
                       <a:r>
-                        <a:rPr lang="en-US" sz="1250" dirty="0">
+                        <a:rPr lang="en-US" sz="1200" dirty="0">
                           <a:solidFill>
                             <a:srgbClr val="23311F"/>
                           </a:solidFill>
@@ -11287,7 +11492,7 @@
                         </a:rPr>
                         <a:t>2</a:t>
                       </a:r>
-                      <a:endParaRPr lang="en-US" sz="1250" dirty="0">
+                      <a:endParaRPr lang="en-US" sz="1200" dirty="0">
                         <a:latin typeface="Microsoft JhengHei" charset="0"/>
                         <a:ea typeface="Microsoft JhengHei" charset="0"/>
                         <a:cs typeface="Microsoft JhengHei" charset="0"/>
@@ -11345,7 +11550,7 @@
                         <a:buNone/>
                       </a:pPr>
                       <a:r>
-                        <a:rPr lang="en-US" sz="1250" dirty="0">
+                        <a:rPr lang="en-US" sz="1200" dirty="0">
                           <a:solidFill>
                             <a:srgbClr val="23311F"/>
                           </a:solidFill>
@@ -11353,9 +11558,9 @@
                           <a:ea typeface="Microsoft JhengHei" pitchFamily="34" charset="-122"/>
                           <a:cs typeface="Microsoft JhengHei" pitchFamily="34" charset="-120"/>
                         </a:rPr>
-                        <a:t>38</a:t>
+                        <a:t>120.0</a:t>
                       </a:r>
-                      <a:endParaRPr lang="en-US" sz="1250" dirty="0">
+                      <a:endParaRPr lang="en-US" sz="1200" dirty="0">
                         <a:latin typeface="Microsoft JhengHei" charset="0"/>
                         <a:ea typeface="Microsoft JhengHei" charset="0"/>
                         <a:cs typeface="Microsoft JhengHei" charset="0"/>
@@ -11413,7 +11618,7 @@
                         <a:buNone/>
                       </a:pPr>
                       <a:r>
-                        <a:rPr lang="en-US" sz="1250" dirty="0">
+                        <a:rPr lang="en-US" sz="1200" dirty="0">
                           <a:solidFill>
                             <a:srgbClr val="23311F"/>
                           </a:solidFill>
@@ -11421,9 +11626,77 @@
                           <a:ea typeface="Microsoft JhengHei" pitchFamily="34" charset="-122"/>
                           <a:cs typeface="Microsoft JhengHei" pitchFamily="34" charset="-120"/>
                         </a:rPr>
-                        <a:t>0</a:t>
+                        <a:t>38.0</a:t>
                       </a:r>
-                      <a:endParaRPr lang="en-US" sz="1250" dirty="0">
+                      <a:endParaRPr lang="en-US" sz="1200" dirty="0">
+                        <a:latin typeface="Microsoft JhengHei" charset="0"/>
+                        <a:ea typeface="Microsoft JhengHei" charset="0"/>
+                        <a:cs typeface="Microsoft JhengHei" charset="0"/>
+                      </a:endParaRPr>
+                    </a:p>
+                  </a:txBody>
+                  <a:tcPr marL="91440" marR="91440" marT="45720" marB="45720" anchor="ctr">
+                    <a:lnL w="12700" cap="flat" cmpd="sng" algn="ctr">
+                      <a:solidFill>
+                        <a:srgbClr val="CBD5C0"/>
+                      </a:solidFill>
+                      <a:prstDash val="solid"/>
+                      <a:round/>
+                      <a:headEnd type="none" w="med" len="med"/>
+                      <a:tailEnd type="none" w="med" len="med"/>
+                    </a:lnL>
+                    <a:lnR w="12700" cap="flat" cmpd="sng" algn="ctr">
+                      <a:solidFill>
+                        <a:srgbClr val="CBD5C0"/>
+                      </a:solidFill>
+                      <a:prstDash val="solid"/>
+                      <a:round/>
+                      <a:headEnd type="none" w="med" len="med"/>
+                      <a:tailEnd type="none" w="med" len="med"/>
+                    </a:lnR>
+                    <a:lnT w="12700" cap="flat" cmpd="sng" algn="ctr">
+                      <a:solidFill>
+                        <a:srgbClr val="CBD5C0"/>
+                      </a:solidFill>
+                      <a:prstDash val="solid"/>
+                      <a:round/>
+                      <a:headEnd type="none" w="med" len="med"/>
+                      <a:tailEnd type="none" w="med" len="med"/>
+                    </a:lnT>
+                    <a:lnB w="12700" cap="flat" cmpd="sng" algn="ctr">
+                      <a:solidFill>
+                        <a:srgbClr val="CBD5C0"/>
+                      </a:solidFill>
+                      <a:prstDash val="solid"/>
+                      <a:round/>
+                      <a:headEnd type="none" w="med" len="med"/>
+                      <a:tailEnd type="none" w="med" len="med"/>
+                    </a:lnB>
+                    <a:solidFill>
+                      <a:srgbClr val="FFFFFF"/>
+                    </a:solidFill>
+                  </a:tcPr>
+                </a:tc>
+                <a:tc>
+                  <a:txBody>
+                    <a:bodyPr/>
+                    <a:lstStyle/>
+                    <a:p>
+                      <a:pPr algn="ctr" indent="0" marL="0">
+                        <a:buNone/>
+                      </a:pPr>
+                      <a:r>
+                        <a:rPr lang="en-US" sz="1200" dirty="0">
+                          <a:solidFill>
+                            <a:srgbClr val="23311F"/>
+                          </a:solidFill>
+                          <a:latin typeface="Microsoft JhengHei" pitchFamily="34" charset="0"/>
+                          <a:ea typeface="Microsoft JhengHei" pitchFamily="34" charset="-122"/>
+                          <a:cs typeface="Microsoft JhengHei" pitchFamily="34" charset="-120"/>
+                        </a:rPr>
+                        <a:t>32%</a:t>
+                      </a:r>
+                      <a:endParaRPr lang="en-US" sz="1200" dirty="0">
                         <a:latin typeface="Microsoft JhengHei" charset="0"/>
                         <a:ea typeface="Microsoft JhengHei" charset="0"/>
                         <a:cs typeface="Microsoft JhengHei" charset="0"/>
@@ -11481,7 +11754,7 @@
                         <a:buNone/>
                       </a:pPr>
                       <a:r>
-                        <a:rPr lang="en-US" sz="1250" dirty="0">
+                        <a:rPr lang="en-US" sz="1200" dirty="0">
                           <a:solidFill>
                             <a:srgbClr val="23311F"/>
                           </a:solidFill>
@@ -11489,9 +11762,9 @@
                           <a:ea typeface="Microsoft JhengHei" pitchFamily="34" charset="-122"/>
                           <a:cs typeface="Microsoft JhengHei" pitchFamily="34" charset="-120"/>
                         </a:rPr>
-                        <a:t>乾燥食用</a:t>
+                        <a:t>兩者皆有 0.0；乾燥食用 38.0</a:t>
                       </a:r>
-                      <a:endParaRPr lang="en-US" sz="1250" dirty="0">
+                      <a:endParaRPr lang="en-US" sz="1200" dirty="0">
                         <a:latin typeface="Microsoft JhengHei" charset="0"/>
                         <a:ea typeface="Microsoft JhengHei" charset="0"/>
                         <a:cs typeface="Microsoft JhengHei" charset="0"/>
@@ -11551,7 +11824,7 @@
                         <a:buNone/>
                       </a:pPr>
                       <a:r>
-                        <a:rPr lang="en-US" sz="1250" b="1" dirty="0">
+                        <a:rPr lang="en-US" sz="1200" b="1" dirty="0">
                           <a:solidFill>
                             <a:srgbClr val="23311F"/>
                           </a:solidFill>
@@ -11561,7 +11834,7 @@
                         </a:rPr>
                         <a:t>張春生</a:t>
                       </a:r>
-                      <a:endParaRPr lang="en-US" sz="1250" dirty="0">
+                      <a:endParaRPr lang="en-US" sz="1200" dirty="0">
                         <a:latin typeface="Microsoft JhengHei" charset="0"/>
                         <a:ea typeface="Microsoft JhengHei" charset="0"/>
                         <a:cs typeface="Microsoft JhengHei" charset="0"/>
@@ -11619,7 +11892,7 @@
                         <a:buNone/>
                       </a:pPr>
                       <a:r>
-                        <a:rPr lang="en-US" sz="1250" dirty="0">
+                        <a:rPr lang="en-US" sz="1200" dirty="0">
                           <a:solidFill>
                             <a:srgbClr val="23311F"/>
                           </a:solidFill>
@@ -11629,7 +11902,7 @@
                         </a:rPr>
                         <a:t>1</a:t>
                       </a:r>
-                      <a:endParaRPr lang="en-US" sz="1250" dirty="0">
+                      <a:endParaRPr lang="en-US" sz="1200" dirty="0">
                         <a:latin typeface="Microsoft JhengHei" charset="0"/>
                         <a:ea typeface="Microsoft JhengHei" charset="0"/>
                         <a:cs typeface="Microsoft JhengHei" charset="0"/>
@@ -11687,7 +11960,7 @@
                         <a:buNone/>
                       </a:pPr>
                       <a:r>
-                        <a:rPr lang="en-US" sz="1250" dirty="0">
+                        <a:rPr lang="en-US" sz="1200" dirty="0">
                           <a:solidFill>
                             <a:srgbClr val="23311F"/>
                           </a:solidFill>
@@ -11695,9 +11968,9 @@
                           <a:ea typeface="Microsoft JhengHei" pitchFamily="34" charset="-122"/>
                           <a:cs typeface="Microsoft JhengHei" pitchFamily="34" charset="-120"/>
                         </a:rPr>
-                        <a:t>0</a:t>
+                        <a:t>50.0</a:t>
                       </a:r>
-                      <a:endParaRPr lang="en-US" sz="1250" dirty="0">
+                      <a:endParaRPr lang="en-US" sz="1200" dirty="0">
                         <a:latin typeface="Microsoft JhengHei" charset="0"/>
                         <a:ea typeface="Microsoft JhengHei" charset="0"/>
                         <a:cs typeface="Microsoft JhengHei" charset="0"/>
@@ -11755,7 +12028,7 @@
                         <a:buNone/>
                       </a:pPr>
                       <a:r>
-                        <a:rPr lang="en-US" sz="1250" dirty="0">
+                        <a:rPr lang="en-US" sz="1200" dirty="0">
                           <a:solidFill>
                             <a:srgbClr val="23311F"/>
                           </a:solidFill>
@@ -11763,9 +12036,77 @@
                           <a:ea typeface="Microsoft JhengHei" pitchFamily="34" charset="-122"/>
                           <a:cs typeface="Microsoft JhengHei" pitchFamily="34" charset="-120"/>
                         </a:rPr>
-                        <a:t>50</a:t>
+                        <a:t>0.0</a:t>
                       </a:r>
-                      <a:endParaRPr lang="en-US" sz="1250" dirty="0">
+                      <a:endParaRPr lang="en-US" sz="1200" dirty="0">
+                        <a:latin typeface="Microsoft JhengHei" charset="0"/>
+                        <a:ea typeface="Microsoft JhengHei" charset="0"/>
+                        <a:cs typeface="Microsoft JhengHei" charset="0"/>
+                      </a:endParaRPr>
+                    </a:p>
+                  </a:txBody>
+                  <a:tcPr marL="91440" marR="91440" marT="45720" marB="45720" anchor="ctr">
+                    <a:lnL w="12700" cap="flat" cmpd="sng" algn="ctr">
+                      <a:solidFill>
+                        <a:srgbClr val="CBD5C0"/>
+                      </a:solidFill>
+                      <a:prstDash val="solid"/>
+                      <a:round/>
+                      <a:headEnd type="none" w="med" len="med"/>
+                      <a:tailEnd type="none" w="med" len="med"/>
+                    </a:lnL>
+                    <a:lnR w="12700" cap="flat" cmpd="sng" algn="ctr">
+                      <a:solidFill>
+                        <a:srgbClr val="CBD5C0"/>
+                      </a:solidFill>
+                      <a:prstDash val="solid"/>
+                      <a:round/>
+                      <a:headEnd type="none" w="med" len="med"/>
+                      <a:tailEnd type="none" w="med" len="med"/>
+                    </a:lnR>
+                    <a:lnT w="12700" cap="flat" cmpd="sng" algn="ctr">
+                      <a:solidFill>
+                        <a:srgbClr val="CBD5C0"/>
+                      </a:solidFill>
+                      <a:prstDash val="solid"/>
+                      <a:round/>
+                      <a:headEnd type="none" w="med" len="med"/>
+                      <a:tailEnd type="none" w="med" len="med"/>
+                    </a:lnT>
+                    <a:lnB w="12700" cap="flat" cmpd="sng" algn="ctr">
+                      <a:solidFill>
+                        <a:srgbClr val="CBD5C0"/>
+                      </a:solidFill>
+                      <a:prstDash val="solid"/>
+                      <a:round/>
+                      <a:headEnd type="none" w="med" len="med"/>
+                      <a:tailEnd type="none" w="med" len="med"/>
+                    </a:lnB>
+                    <a:solidFill>
+                      <a:srgbClr val="F4F6F1"/>
+                    </a:solidFill>
+                  </a:tcPr>
+                </a:tc>
+                <a:tc>
+                  <a:txBody>
+                    <a:bodyPr/>
+                    <a:lstStyle/>
+                    <a:p>
+                      <a:pPr algn="ctr" indent="0" marL="0">
+                        <a:buNone/>
+                      </a:pPr>
+                      <a:r>
+                        <a:rPr lang="en-US" sz="1200" dirty="0">
+                          <a:solidFill>
+                            <a:srgbClr val="23311F"/>
+                          </a:solidFill>
+                          <a:latin typeface="Microsoft JhengHei" pitchFamily="34" charset="0"/>
+                          <a:ea typeface="Microsoft JhengHei" pitchFamily="34" charset="-122"/>
+                          <a:cs typeface="Microsoft JhengHei" pitchFamily="34" charset="-120"/>
+                        </a:rPr>
+                        <a:t>0%</a:t>
+                      </a:r>
+                      <a:endParaRPr lang="en-US" sz="1200" dirty="0">
                         <a:latin typeface="Microsoft JhengHei" charset="0"/>
                         <a:ea typeface="Microsoft JhengHei" charset="0"/>
                         <a:cs typeface="Microsoft JhengHei" charset="0"/>
@@ -11823,7 +12164,7 @@
                         <a:buNone/>
                       </a:pPr>
                       <a:r>
-                        <a:rPr lang="en-US" sz="1250" dirty="0">
+                        <a:rPr lang="en-US" sz="1200" dirty="0">
                           <a:solidFill>
                             <a:srgbClr val="23311F"/>
                           </a:solidFill>
@@ -11831,9 +12172,9 @@
                           <a:ea typeface="Microsoft JhengHei" pitchFamily="34" charset="-122"/>
                           <a:cs typeface="Microsoft JhengHei" pitchFamily="34" charset="-120"/>
                         </a:rPr>
-                        <a:t>精油萃取</a:t>
+                        <a:t>精油萃取 0.0</a:t>
                       </a:r>
-                      <a:endParaRPr lang="en-US" sz="1250" dirty="0">
+                      <a:endParaRPr lang="en-US" sz="1200" dirty="0">
                         <a:latin typeface="Microsoft JhengHei" charset="0"/>
                         <a:ea typeface="Microsoft JhengHei" charset="0"/>
                         <a:cs typeface="Microsoft JhengHei" charset="0"/>
@@ -11893,7 +12234,7 @@
                         <a:buNone/>
                       </a:pPr>
                       <a:r>
-                        <a:rPr lang="en-US" sz="1250" b="1" dirty="0">
+                        <a:rPr lang="en-US" sz="1200" b="1" dirty="0">
                           <a:solidFill>
                             <a:srgbClr val="23311F"/>
                           </a:solidFill>
@@ -11903,7 +12244,7 @@
                         </a:rPr>
                         <a:t>黃秋蘭</a:t>
                       </a:r>
-                      <a:endParaRPr lang="en-US" sz="1250" dirty="0">
+                      <a:endParaRPr lang="en-US" sz="1200" dirty="0">
                         <a:latin typeface="Microsoft JhengHei" charset="0"/>
                         <a:ea typeface="Microsoft JhengHei" charset="0"/>
                         <a:cs typeface="Microsoft JhengHei" charset="0"/>
@@ -11961,7 +12302,7 @@
                         <a:buNone/>
                       </a:pPr>
                       <a:r>
-                        <a:rPr lang="en-US" sz="1250" dirty="0">
+                        <a:rPr lang="en-US" sz="1200" dirty="0">
                           <a:solidFill>
                             <a:srgbClr val="23311F"/>
                           </a:solidFill>
@@ -11971,7 +12312,7 @@
                         </a:rPr>
                         <a:t>1</a:t>
                       </a:r>
-                      <a:endParaRPr lang="en-US" sz="1250" dirty="0">
+                      <a:endParaRPr lang="en-US" sz="1200" dirty="0">
                         <a:latin typeface="Microsoft JhengHei" charset="0"/>
                         <a:ea typeface="Microsoft JhengHei" charset="0"/>
                         <a:cs typeface="Microsoft JhengHei" charset="0"/>
@@ -12029,7 +12370,7 @@
                         <a:buNone/>
                       </a:pPr>
                       <a:r>
-                        <a:rPr lang="en-US" sz="1250" dirty="0">
+                        <a:rPr lang="en-US" sz="1200" dirty="0">
                           <a:solidFill>
                             <a:srgbClr val="23311F"/>
                           </a:solidFill>
@@ -12037,9 +12378,9 @@
                           <a:ea typeface="Microsoft JhengHei" pitchFamily="34" charset="-122"/>
                           <a:cs typeface="Microsoft JhengHei" pitchFamily="34" charset="-120"/>
                         </a:rPr>
-                        <a:t>0</a:t>
+                        <a:t>70.0</a:t>
                       </a:r>
-                      <a:endParaRPr lang="en-US" sz="1250" dirty="0">
+                      <a:endParaRPr lang="en-US" sz="1200" dirty="0">
                         <a:latin typeface="Microsoft JhengHei" charset="0"/>
                         <a:ea typeface="Microsoft JhengHei" charset="0"/>
                         <a:cs typeface="Microsoft JhengHei" charset="0"/>
@@ -12097,7 +12438,7 @@
                         <a:buNone/>
                       </a:pPr>
                       <a:r>
-                        <a:rPr lang="en-US" sz="1250" dirty="0">
+                        <a:rPr lang="en-US" sz="1200" dirty="0">
                           <a:solidFill>
                             <a:srgbClr val="23311F"/>
                           </a:solidFill>
@@ -12105,9 +12446,77 @@
                           <a:ea typeface="Microsoft JhengHei" pitchFamily="34" charset="-122"/>
                           <a:cs typeface="Microsoft JhengHei" pitchFamily="34" charset="-120"/>
                         </a:rPr>
-                        <a:t>60</a:t>
+                        <a:t>0.0</a:t>
                       </a:r>
-                      <a:endParaRPr lang="en-US" sz="1250" dirty="0">
+                      <a:endParaRPr lang="en-US" sz="1200" dirty="0">
+                        <a:latin typeface="Microsoft JhengHei" charset="0"/>
+                        <a:ea typeface="Microsoft JhengHei" charset="0"/>
+                        <a:cs typeface="Microsoft JhengHei" charset="0"/>
+                      </a:endParaRPr>
+                    </a:p>
+                  </a:txBody>
+                  <a:tcPr marL="91440" marR="91440" marT="45720" marB="45720" anchor="ctr">
+                    <a:lnL w="12700" cap="flat" cmpd="sng" algn="ctr">
+                      <a:solidFill>
+                        <a:srgbClr val="CBD5C0"/>
+                      </a:solidFill>
+                      <a:prstDash val="solid"/>
+                      <a:round/>
+                      <a:headEnd type="none" w="med" len="med"/>
+                      <a:tailEnd type="none" w="med" len="med"/>
+                    </a:lnL>
+                    <a:lnR w="12700" cap="flat" cmpd="sng" algn="ctr">
+                      <a:solidFill>
+                        <a:srgbClr val="CBD5C0"/>
+                      </a:solidFill>
+                      <a:prstDash val="solid"/>
+                      <a:round/>
+                      <a:headEnd type="none" w="med" len="med"/>
+                      <a:tailEnd type="none" w="med" len="med"/>
+                    </a:lnR>
+                    <a:lnT w="12700" cap="flat" cmpd="sng" algn="ctr">
+                      <a:solidFill>
+                        <a:srgbClr val="CBD5C0"/>
+                      </a:solidFill>
+                      <a:prstDash val="solid"/>
+                      <a:round/>
+                      <a:headEnd type="none" w="med" len="med"/>
+                      <a:tailEnd type="none" w="med" len="med"/>
+                    </a:lnT>
+                    <a:lnB w="12700" cap="flat" cmpd="sng" algn="ctr">
+                      <a:solidFill>
+                        <a:srgbClr val="CBD5C0"/>
+                      </a:solidFill>
+                      <a:prstDash val="solid"/>
+                      <a:round/>
+                      <a:headEnd type="none" w="med" len="med"/>
+                      <a:tailEnd type="none" w="med" len="med"/>
+                    </a:lnB>
+                    <a:solidFill>
+                      <a:srgbClr val="FFFFFF"/>
+                    </a:solidFill>
+                  </a:tcPr>
+                </a:tc>
+                <a:tc>
+                  <a:txBody>
+                    <a:bodyPr/>
+                    <a:lstStyle/>
+                    <a:p>
+                      <a:pPr algn="ctr" indent="0" marL="0">
+                        <a:buNone/>
+                      </a:pPr>
+                      <a:r>
+                        <a:rPr lang="en-US" sz="1200" dirty="0">
+                          <a:solidFill>
+                            <a:srgbClr val="23311F"/>
+                          </a:solidFill>
+                          <a:latin typeface="Microsoft JhengHei" pitchFamily="34" charset="0"/>
+                          <a:ea typeface="Microsoft JhengHei" pitchFamily="34" charset="-122"/>
+                          <a:cs typeface="Microsoft JhengHei" pitchFamily="34" charset="-120"/>
+                        </a:rPr>
+                        <a:t>0%</a:t>
+                      </a:r>
+                      <a:endParaRPr lang="en-US" sz="1200" dirty="0">
                         <a:latin typeface="Microsoft JhengHei" charset="0"/>
                         <a:ea typeface="Microsoft JhengHei" charset="0"/>
                         <a:cs typeface="Microsoft JhengHei" charset="0"/>
@@ -12165,7 +12574,7 @@
                         <a:buNone/>
                       </a:pPr>
                       <a:r>
-                        <a:rPr lang="en-US" sz="1250" dirty="0">
+                        <a:rPr lang="en-US" sz="1200" dirty="0">
                           <a:solidFill>
                             <a:srgbClr val="23311F"/>
                           </a:solidFill>
@@ -12173,9 +12582,9 @@
                           <a:ea typeface="Microsoft JhengHei" pitchFamily="34" charset="-122"/>
                           <a:cs typeface="Microsoft JhengHei" pitchFamily="34" charset="-120"/>
                         </a:rPr>
-                        <a:t>乾燥食用</a:t>
+                        <a:t>乾燥食用 0.0</a:t>
                       </a:r>
-                      <a:endParaRPr lang="en-US" sz="1250" dirty="0">
+                      <a:endParaRPr lang="en-US" sz="1200" dirty="0">
                         <a:latin typeface="Microsoft JhengHei" charset="0"/>
                         <a:ea typeface="Microsoft JhengHei" charset="0"/>
                         <a:cs typeface="Microsoft JhengHei" charset="0"/>
@@ -12235,7 +12644,7 @@
                         <a:buNone/>
                       </a:pPr>
                       <a:r>
-                        <a:rPr lang="en-US" sz="1250" b="1" dirty="0">
+                        <a:rPr lang="en-US" sz="1200" b="1" dirty="0">
                           <a:solidFill>
                             <a:srgbClr val="23311F"/>
                           </a:solidFill>
@@ -12245,7 +12654,7 @@
                         </a:rPr>
                         <a:t>陳阿土</a:t>
                       </a:r>
-                      <a:endParaRPr lang="en-US" sz="1250" dirty="0">
+                      <a:endParaRPr lang="en-US" sz="1200" dirty="0">
                         <a:latin typeface="Microsoft JhengHei" charset="0"/>
                         <a:ea typeface="Microsoft JhengHei" charset="0"/>
                         <a:cs typeface="Microsoft JhengHei" charset="0"/>
@@ -12303,7 +12712,7 @@
                         <a:buNone/>
                       </a:pPr>
                       <a:r>
-                        <a:rPr lang="en-US" sz="1250" dirty="0">
+                        <a:rPr lang="en-US" sz="1200" dirty="0">
                           <a:solidFill>
                             <a:srgbClr val="23311F"/>
                           </a:solidFill>
@@ -12313,7 +12722,7 @@
                         </a:rPr>
                         <a:t>1</a:t>
                       </a:r>
-                      <a:endParaRPr lang="en-US" sz="1250" dirty="0">
+                      <a:endParaRPr lang="en-US" sz="1200" dirty="0">
                         <a:latin typeface="Microsoft JhengHei" charset="0"/>
                         <a:ea typeface="Microsoft JhengHei" charset="0"/>
                         <a:cs typeface="Microsoft JhengHei" charset="0"/>
@@ -12371,7 +12780,7 @@
                         <a:buNone/>
                       </a:pPr>
                       <a:r>
-                        <a:rPr lang="en-US" sz="1250" dirty="0">
+                        <a:rPr lang="en-US" sz="1200" dirty="0">
                           <a:solidFill>
                             <a:srgbClr val="23311F"/>
                           </a:solidFill>
@@ -12379,9 +12788,9 @@
                           <a:ea typeface="Microsoft JhengHei" pitchFamily="34" charset="-122"/>
                           <a:cs typeface="Microsoft JhengHei" pitchFamily="34" charset="-120"/>
                         </a:rPr>
-                        <a:t>0</a:t>
+                        <a:t>45.0</a:t>
                       </a:r>
-                      <a:endParaRPr lang="en-US" sz="1250" dirty="0">
+                      <a:endParaRPr lang="en-US" sz="1200" dirty="0">
                         <a:latin typeface="Microsoft JhengHei" charset="0"/>
                         <a:ea typeface="Microsoft JhengHei" charset="0"/>
                         <a:cs typeface="Microsoft JhengHei" charset="0"/>
@@ -12439,7 +12848,7 @@
                         <a:buNone/>
                       </a:pPr>
                       <a:r>
-                        <a:rPr lang="en-US" sz="1250" dirty="0">
+                        <a:rPr lang="en-US" sz="1200" dirty="0">
                           <a:solidFill>
                             <a:srgbClr val="23311F"/>
                           </a:solidFill>
@@ -12447,9 +12856,77 @@
                           <a:ea typeface="Microsoft JhengHei" pitchFamily="34" charset="-122"/>
                           <a:cs typeface="Microsoft JhengHei" pitchFamily="34" charset="-120"/>
                         </a:rPr>
-                        <a:t>45</a:t>
+                        <a:t>0.0</a:t>
                       </a:r>
-                      <a:endParaRPr lang="en-US" sz="1250" dirty="0">
+                      <a:endParaRPr lang="en-US" sz="1200" dirty="0">
+                        <a:latin typeface="Microsoft JhengHei" charset="0"/>
+                        <a:ea typeface="Microsoft JhengHei" charset="0"/>
+                        <a:cs typeface="Microsoft JhengHei" charset="0"/>
+                      </a:endParaRPr>
+                    </a:p>
+                  </a:txBody>
+                  <a:tcPr marL="91440" marR="91440" marT="45720" marB="45720" anchor="ctr">
+                    <a:lnL w="12700" cap="flat" cmpd="sng" algn="ctr">
+                      <a:solidFill>
+                        <a:srgbClr val="CBD5C0"/>
+                      </a:solidFill>
+                      <a:prstDash val="solid"/>
+                      <a:round/>
+                      <a:headEnd type="none" w="med" len="med"/>
+                      <a:tailEnd type="none" w="med" len="med"/>
+                    </a:lnL>
+                    <a:lnR w="12700" cap="flat" cmpd="sng" algn="ctr">
+                      <a:solidFill>
+                        <a:srgbClr val="CBD5C0"/>
+                      </a:solidFill>
+                      <a:prstDash val="solid"/>
+                      <a:round/>
+                      <a:headEnd type="none" w="med" len="med"/>
+                      <a:tailEnd type="none" w="med" len="med"/>
+                    </a:lnR>
+                    <a:lnT w="12700" cap="flat" cmpd="sng" algn="ctr">
+                      <a:solidFill>
+                        <a:srgbClr val="CBD5C0"/>
+                      </a:solidFill>
+                      <a:prstDash val="solid"/>
+                      <a:round/>
+                      <a:headEnd type="none" w="med" len="med"/>
+                      <a:tailEnd type="none" w="med" len="med"/>
+                    </a:lnT>
+                    <a:lnB w="12700" cap="flat" cmpd="sng" algn="ctr">
+                      <a:solidFill>
+                        <a:srgbClr val="CBD5C0"/>
+                      </a:solidFill>
+                      <a:prstDash val="solid"/>
+                      <a:round/>
+                      <a:headEnd type="none" w="med" len="med"/>
+                      <a:tailEnd type="none" w="med" len="med"/>
+                    </a:lnB>
+                    <a:solidFill>
+                      <a:srgbClr val="F4F6F1"/>
+                    </a:solidFill>
+                  </a:tcPr>
+                </a:tc>
+                <a:tc>
+                  <a:txBody>
+                    <a:bodyPr/>
+                    <a:lstStyle/>
+                    <a:p>
+                      <a:pPr algn="ctr" indent="0" marL="0">
+                        <a:buNone/>
+                      </a:pPr>
+                      <a:r>
+                        <a:rPr lang="en-US" sz="1200" dirty="0">
+                          <a:solidFill>
+                            <a:srgbClr val="23311F"/>
+                          </a:solidFill>
+                          <a:latin typeface="Microsoft JhengHei" pitchFamily="34" charset="0"/>
+                          <a:ea typeface="Microsoft JhengHei" pitchFamily="34" charset="-122"/>
+                          <a:cs typeface="Microsoft JhengHei" pitchFamily="34" charset="-120"/>
+                        </a:rPr>
+                        <a:t>0%</a:t>
+                      </a:r>
+                      <a:endParaRPr lang="en-US" sz="1200" dirty="0">
                         <a:latin typeface="Microsoft JhengHei" charset="0"/>
                         <a:ea typeface="Microsoft JhengHei" charset="0"/>
                         <a:cs typeface="Microsoft JhengHei" charset="0"/>
@@ -12507,7 +12984,7 @@
                         <a:buNone/>
                       </a:pPr>
                       <a:r>
-                        <a:rPr lang="en-US" sz="1250" dirty="0">
+                        <a:rPr lang="en-US" sz="1200" dirty="0">
                           <a:solidFill>
                             <a:srgbClr val="23311F"/>
                           </a:solidFill>
@@ -12515,9 +12992,9 @@
                           <a:ea typeface="Microsoft JhengHei" pitchFamily="34" charset="-122"/>
                           <a:cs typeface="Microsoft JhengHei" pitchFamily="34" charset="-120"/>
                         </a:rPr>
-                        <a:t>乾燥食用</a:t>
+                        <a:t>乾燥食用 0.0</a:t>
                       </a:r>
-                      <a:endParaRPr lang="en-US" sz="1250" dirty="0">
+                      <a:endParaRPr lang="en-US" sz="1200" dirty="0">
                         <a:latin typeface="Microsoft JhengHei" charset="0"/>
                         <a:ea typeface="Microsoft JhengHei" charset="0"/>
                         <a:cs typeface="Microsoft JhengHei" charset="0"/>
@@ -12577,7 +13054,7 @@
                         <a:buNone/>
                       </a:pPr>
                       <a:r>
-                        <a:rPr lang="en-US" sz="1250" b="1" dirty="0">
+                        <a:rPr lang="en-US" sz="1200" b="1" dirty="0">
                           <a:solidFill>
                             <a:srgbClr val="23311F"/>
                           </a:solidFill>
@@ -12587,7 +13064,7 @@
                         </a:rPr>
                         <a:t>李文清</a:t>
                       </a:r>
-                      <a:endParaRPr lang="en-US" sz="1250" dirty="0">
+                      <a:endParaRPr lang="en-US" sz="1200" dirty="0">
                         <a:latin typeface="Microsoft JhengHei" charset="0"/>
                         <a:ea typeface="Microsoft JhengHei" charset="0"/>
                         <a:cs typeface="Microsoft JhengHei" charset="0"/>
@@ -12645,7 +13122,7 @@
                         <a:buNone/>
                       </a:pPr>
                       <a:r>
-                        <a:rPr lang="en-US" sz="1250" dirty="0">
+                        <a:rPr lang="en-US" sz="1200" dirty="0">
                           <a:solidFill>
                             <a:srgbClr val="23311F"/>
                           </a:solidFill>
@@ -12655,7 +13132,7 @@
                         </a:rPr>
                         <a:t>1</a:t>
                       </a:r>
-                      <a:endParaRPr lang="en-US" sz="1250" dirty="0">
+                      <a:endParaRPr lang="en-US" sz="1200" dirty="0">
                         <a:latin typeface="Microsoft JhengHei" charset="0"/>
                         <a:ea typeface="Microsoft JhengHei" charset="0"/>
                         <a:cs typeface="Microsoft JhengHei" charset="0"/>
@@ -12713,7 +13190,7 @@
                         <a:buNone/>
                       </a:pPr>
                       <a:r>
-                        <a:rPr lang="en-US" sz="1250" dirty="0">
+                        <a:rPr lang="en-US" sz="1200" dirty="0">
                           <a:solidFill>
                             <a:srgbClr val="23311F"/>
                           </a:solidFill>
@@ -12721,9 +13198,9 @@
                           <a:ea typeface="Microsoft JhengHei" pitchFamily="34" charset="-122"/>
                           <a:cs typeface="Microsoft JhengHei" pitchFamily="34" charset="-120"/>
                         </a:rPr>
-                        <a:t>0</a:t>
+                        <a:t>120.0</a:t>
                       </a:r>
-                      <a:endParaRPr lang="en-US" sz="1250" dirty="0">
+                      <a:endParaRPr lang="en-US" sz="1200" dirty="0">
                         <a:latin typeface="Microsoft JhengHei" charset="0"/>
                         <a:ea typeface="Microsoft JhengHei" charset="0"/>
                         <a:cs typeface="Microsoft JhengHei" charset="0"/>
@@ -12781,7 +13258,7 @@
                         <a:buNone/>
                       </a:pPr>
                       <a:r>
-                        <a:rPr lang="en-US" sz="1250" dirty="0">
+                        <a:rPr lang="en-US" sz="1200" dirty="0">
                           <a:solidFill>
                             <a:srgbClr val="23311F"/>
                           </a:solidFill>
@@ -12789,9 +13266,77 @@
                           <a:ea typeface="Microsoft JhengHei" pitchFamily="34" charset="-122"/>
                           <a:cs typeface="Microsoft JhengHei" pitchFamily="34" charset="-120"/>
                         </a:rPr>
-                        <a:t>0</a:t>
+                        <a:t>0.0</a:t>
                       </a:r>
-                      <a:endParaRPr lang="en-US" sz="1250" dirty="0">
+                      <a:endParaRPr lang="en-US" sz="1200" dirty="0">
+                        <a:latin typeface="Microsoft JhengHei" charset="0"/>
+                        <a:ea typeface="Microsoft JhengHei" charset="0"/>
+                        <a:cs typeface="Microsoft JhengHei" charset="0"/>
+                      </a:endParaRPr>
+                    </a:p>
+                  </a:txBody>
+                  <a:tcPr marL="91440" marR="91440" marT="45720" marB="45720" anchor="ctr">
+                    <a:lnL w="12700" cap="flat" cmpd="sng" algn="ctr">
+                      <a:solidFill>
+                        <a:srgbClr val="CBD5C0"/>
+                      </a:solidFill>
+                      <a:prstDash val="solid"/>
+                      <a:round/>
+                      <a:headEnd type="none" w="med" len="med"/>
+                      <a:tailEnd type="none" w="med" len="med"/>
+                    </a:lnL>
+                    <a:lnR w="12700" cap="flat" cmpd="sng" algn="ctr">
+                      <a:solidFill>
+                        <a:srgbClr val="CBD5C0"/>
+                      </a:solidFill>
+                      <a:prstDash val="solid"/>
+                      <a:round/>
+                      <a:headEnd type="none" w="med" len="med"/>
+                      <a:tailEnd type="none" w="med" len="med"/>
+                    </a:lnR>
+                    <a:lnT w="12700" cap="flat" cmpd="sng" algn="ctr">
+                      <a:solidFill>
+                        <a:srgbClr val="CBD5C0"/>
+                      </a:solidFill>
+                      <a:prstDash val="solid"/>
+                      <a:round/>
+                      <a:headEnd type="none" w="med" len="med"/>
+                      <a:tailEnd type="none" w="med" len="med"/>
+                    </a:lnT>
+                    <a:lnB w="12700" cap="flat" cmpd="sng" algn="ctr">
+                      <a:solidFill>
+                        <a:srgbClr val="CBD5C0"/>
+                      </a:solidFill>
+                      <a:prstDash val="solid"/>
+                      <a:round/>
+                      <a:headEnd type="none" w="med" len="med"/>
+                      <a:tailEnd type="none" w="med" len="med"/>
+                    </a:lnB>
+                    <a:solidFill>
+                      <a:srgbClr val="FFFFFF"/>
+                    </a:solidFill>
+                  </a:tcPr>
+                </a:tc>
+                <a:tc>
+                  <a:txBody>
+                    <a:bodyPr/>
+                    <a:lstStyle/>
+                    <a:p>
+                      <a:pPr algn="ctr" indent="0" marL="0">
+                        <a:buNone/>
+                      </a:pPr>
+                      <a:r>
+                        <a:rPr lang="en-US" sz="1200" dirty="0">
+                          <a:solidFill>
+                            <a:srgbClr val="23311F"/>
+                          </a:solidFill>
+                          <a:latin typeface="Microsoft JhengHei" pitchFamily="34" charset="0"/>
+                          <a:ea typeface="Microsoft JhengHei" pitchFamily="34" charset="-122"/>
+                          <a:cs typeface="Microsoft JhengHei" pitchFamily="34" charset="-120"/>
+                        </a:rPr>
+                        <a:t>0%</a:t>
+                      </a:r>
+                      <a:endParaRPr lang="en-US" sz="1200" dirty="0">
                         <a:latin typeface="Microsoft JhengHei" charset="0"/>
                         <a:ea typeface="Microsoft JhengHei" charset="0"/>
                         <a:cs typeface="Microsoft JhengHei" charset="0"/>
@@ -12849,7 +13394,7 @@
                         <a:buNone/>
                       </a:pPr>
                       <a:r>
-                        <a:rPr lang="en-US" sz="1250" dirty="0">
+                        <a:rPr lang="en-US" sz="1200" dirty="0">
                           <a:solidFill>
                             <a:srgbClr val="23311F"/>
                           </a:solidFill>
@@ -12857,9 +13402,9 @@
                           <a:ea typeface="Microsoft JhengHei" pitchFamily="34" charset="-122"/>
                           <a:cs typeface="Microsoft JhengHei" pitchFamily="34" charset="-120"/>
                         </a:rPr>
-                        <a:t>精油萃取（已駁回）</a:t>
+                        <a:t>精油萃取 0.0</a:t>
                       </a:r>
-                      <a:endParaRPr lang="en-US" sz="1250" dirty="0">
+                      <a:endParaRPr lang="en-US" sz="1200" dirty="0">
                         <a:latin typeface="Microsoft JhengHei" charset="0"/>
                         <a:ea typeface="Microsoft JhengHei" charset="0"/>
                         <a:cs typeface="Microsoft JhengHei" charset="0"/>
@@ -12921,8 +13466,8 @@
         </p:nvSpPr>
         <p:spPr>
           <a:xfrm>
-            <a:off x="640080" y="5989320"/>
-            <a:ext cx="10911535" cy="365760"/>
+            <a:off x="640080" y="5943600"/>
+            <a:ext cx="10911535" cy="320040"/>
           </a:xfrm>
           <a:prstGeom prst="rect">
             <a:avLst/>
@@ -12946,7 +13491,7 @@
                 <a:ea typeface="Microsoft JhengHei" pitchFamily="34" charset="-122"/>
                 <a:cs typeface="Microsoft JhengHei" pitchFamily="34" charset="-120"/>
               </a:rPr>
-              <a:t>「已實現」＝實際登錄收穫累計（採收中／已結案）即可投入共同銷售；Pipeline＝已送出／已核准但尚未採收之預估量</a:t>
+              <a:t>「申請量」＝申請當時預計鮮葉量；「已回報」＝核准後實際採收回報累計（採收中/已結案），即可投入共同銷售之數量；達成率＝已回報 ÷ 申請量。</a:t>
             </a:r>
             <a:endParaRPr lang="en-US" sz="1100" dirty="0"/>
           </a:p>
@@ -12955,6 +13500,45 @@
       <p:sp>
         <p:nvSpPr>
           <p:cNvPr id="15" name="Text 12"/>
+          <p:cNvSpPr/>
+          <p:nvPr/>
+        </p:nvSpPr>
+        <p:spPr>
+          <a:xfrm>
+            <a:off x="640080" y="6236208"/>
+            <a:ext cx="10911535" cy="274320"/>
+          </a:xfrm>
+          <a:prstGeom prst="rect">
+            <a:avLst/>
+          </a:prstGeom>
+          <a:noFill/>
+          <a:ln/>
+        </p:spPr>
+        <p:txBody>
+          <a:bodyPr wrap="square" lIns="0" tIns="0" rIns="0" bIns="0" rtlCol="0" anchor="ctr"/>
+          <a:lstStyle/>
+          <a:p>
+            <a:pPr indent="0" marL="0">
+              <a:buNone/>
+            </a:pPr>
+            <a:r>
+              <a:rPr lang="en-US" sz="1050" dirty="0">
+                <a:solidFill>
+                  <a:srgbClr val="2C5F2D"/>
+                </a:solidFill>
+                <a:latin typeface="Microsoft JhengHei" pitchFamily="34" charset="0"/>
+                <a:ea typeface="Microsoft JhengHei" pitchFamily="34" charset="-122"/>
+                <a:cs typeface="Microsoft JhengHei" pitchFamily="34" charset="-120"/>
+              </a:rPr>
+              <a:t>本表即合作社「採收彙整」分頁的即時畫面（依已回報遞減排序），現場可逐列對照</a:t>
+            </a:r>
+            <a:endParaRPr lang="en-US" sz="1050" dirty="0"/>
+          </a:p>
+        </p:txBody>
+      </p:sp>
+      <p:sp>
+        <p:nvSpPr>
+          <p:cNvPr id="16" name="Text 13"/>
           <p:cNvSpPr/>
           <p:nvPr/>
         </p:nvSpPr>

</xml_diff>